<commit_message>
add new pages, templates, CSS variables, and update existing files
- Add about.html, css/variables.css, html/templates/, templates/
- Add document templates (lettre, CV, charte)
- Update CSS and HTML files
- Untrack .DS_Store

Co-Authored-By: Claude Sonnet 4.6 <noreply@anthropic.com>
</commit_message>
<xml_diff>
--- a/repos/website/template_charte.pptx
+++ b/repos/website/template_charte.pptx
@@ -14,9 +14,11 @@
     <p:sldId id="262" r:id="rId8"/>
     <p:sldId id="263" r:id="rId9"/>
     <p:sldId id="264" r:id="rId10"/>
+    <p:sldId id="265" r:id="rId11"/>
+    <p:sldId id="266" r:id="rId12"/>
   </p:sldIdLst>
   <p:notesMasterIdLst>
-    <p:notesMasterId r:id="rId11"/>
+    <p:notesMasterId r:id="rId13"/>
   </p:notesMasterIdLst>
   <p:sldSz cx="9144000" cy="5143500"/>
   <p:notesSz cx="5143500" cy="9144000"/>
@@ -534,6 +536,182 @@
             <a:fld id="{F7021451-1387-4CA6-816F-3879F97B5CBC}" type="slidenum">
               <a:rPr lang="en-US"/>
               <a:t>1</a:t>
+            </a:fld>
+            <a:endParaRPr lang="en-US"/>
+          </a:p>
+        </p:txBody>
+      </p:sp>
+    </p:spTree>
+    <p:extLst>
+      <p:ext uri="{BB962C8B-B14F-4D97-AF65-F5344CB8AC3E}">
+        <p14:creationId xmlns:p14="http://schemas.microsoft.com/office/powerpoint/2010/main" val="1024086991"/>
+      </p:ext>
+    </p:extLst>
+  </p:cSld>
+  <p:clrMapOvr>
+    <a:masterClrMapping/>
+  </p:clrMapOvr>
+</p:notes>
+</file>
+
+<file path=ppt/notesSlides/notesSlide10.xml><?xml version="1.0" encoding="utf-8"?>
+<p:notes xmlns:a="http://schemas.openxmlformats.org/drawingml/2006/main" xmlns:r="http://schemas.openxmlformats.org/officeDocument/2006/relationships" xmlns:p="http://schemas.openxmlformats.org/presentationml/2006/main">
+  <p:cSld>
+    <p:spTree>
+      <p:nvGrpSpPr>
+        <p:cNvPr id="1" name=""/>
+        <p:cNvGrpSpPr/>
+        <p:nvPr/>
+      </p:nvGrpSpPr>
+      <p:grpSpPr>
+        <a:xfrm>
+          <a:off x="0" y="0"/>
+          <a:ext cx="0" cy="0"/>
+          <a:chOff x="0" y="0"/>
+          <a:chExt cx="0" cy="0"/>
+        </a:xfrm>
+      </p:grpSpPr>
+      <p:sp>
+        <p:nvSpPr>
+          <p:cNvPr id="2" name="Slide Image Placeholder 1"/>
+          <p:cNvSpPr>
+            <a:spLocks noGrp="1" noRot="1" noChangeAspect="1"/>
+          </p:cNvSpPr>
+          <p:nvPr>
+            <p:ph type="sldImg"/>
+          </p:nvPr>
+        </p:nvSpPr>
+        <p:spPr/>
+      </p:sp>
+      <p:sp>
+        <p:nvSpPr>
+          <p:cNvPr id="3" name="Notes Placeholder 2"/>
+          <p:cNvSpPr>
+            <a:spLocks noGrp="1"/>
+          </p:cNvSpPr>
+          <p:nvPr>
+            <p:ph type="body" idx="1"/>
+          </p:nvPr>
+        </p:nvSpPr>
+        <p:spPr/>
+        <p:txBody>
+          <a:bodyPr/>
+          <a:lstStyle/>
+          <a:p>
+            <a:r>
+              <a:rPr lang="en-US" dirty="0"/>
+              <a:t/>
+            </a:r>
+            <a:endParaRPr lang="en-US" dirty="0"/>
+          </a:p>
+        </p:txBody>
+      </p:sp>
+      <p:sp>
+        <p:nvSpPr>
+          <p:cNvPr id="4" name="Slide Number Placeholder 3"/>
+          <p:cNvSpPr>
+            <a:spLocks noGrp="1"/>
+          </p:cNvSpPr>
+          <p:nvPr>
+            <p:ph type="sldNum" sz="quarter" idx="10"/>
+          </p:nvPr>
+        </p:nvSpPr>
+        <p:spPr/>
+        <p:txBody>
+          <a:bodyPr/>
+          <a:lstStyle/>
+          <a:p>
+            <a:fld id="{F7021451-1387-4CA6-816F-3879F97B5CBC}" type="slidenum">
+              <a:rPr lang="en-US"/>
+              <a:t>10</a:t>
+            </a:fld>
+            <a:endParaRPr lang="en-US"/>
+          </a:p>
+        </p:txBody>
+      </p:sp>
+    </p:spTree>
+    <p:extLst>
+      <p:ext uri="{BB962C8B-B14F-4D97-AF65-F5344CB8AC3E}">
+        <p14:creationId xmlns:p14="http://schemas.microsoft.com/office/powerpoint/2010/main" val="1024086991"/>
+      </p:ext>
+    </p:extLst>
+  </p:cSld>
+  <p:clrMapOvr>
+    <a:masterClrMapping/>
+  </p:clrMapOvr>
+</p:notes>
+</file>
+
+<file path=ppt/notesSlides/notesSlide11.xml><?xml version="1.0" encoding="utf-8"?>
+<p:notes xmlns:a="http://schemas.openxmlformats.org/drawingml/2006/main" xmlns:r="http://schemas.openxmlformats.org/officeDocument/2006/relationships" xmlns:p="http://schemas.openxmlformats.org/presentationml/2006/main">
+  <p:cSld>
+    <p:spTree>
+      <p:nvGrpSpPr>
+        <p:cNvPr id="1" name=""/>
+        <p:cNvGrpSpPr/>
+        <p:nvPr/>
+      </p:nvGrpSpPr>
+      <p:grpSpPr>
+        <a:xfrm>
+          <a:off x="0" y="0"/>
+          <a:ext cx="0" cy="0"/>
+          <a:chOff x="0" y="0"/>
+          <a:chExt cx="0" cy="0"/>
+        </a:xfrm>
+      </p:grpSpPr>
+      <p:sp>
+        <p:nvSpPr>
+          <p:cNvPr id="2" name="Slide Image Placeholder 1"/>
+          <p:cNvSpPr>
+            <a:spLocks noGrp="1" noRot="1" noChangeAspect="1"/>
+          </p:cNvSpPr>
+          <p:nvPr>
+            <p:ph type="sldImg"/>
+          </p:nvPr>
+        </p:nvSpPr>
+        <p:spPr/>
+      </p:sp>
+      <p:sp>
+        <p:nvSpPr>
+          <p:cNvPr id="3" name="Notes Placeholder 2"/>
+          <p:cNvSpPr>
+            <a:spLocks noGrp="1"/>
+          </p:cNvSpPr>
+          <p:nvPr>
+            <p:ph type="body" idx="1"/>
+          </p:nvPr>
+        </p:nvSpPr>
+        <p:spPr/>
+        <p:txBody>
+          <a:bodyPr/>
+          <a:lstStyle/>
+          <a:p>
+            <a:r>
+              <a:rPr lang="en-US" dirty="0"/>
+              <a:t/>
+            </a:r>
+            <a:endParaRPr lang="en-US" dirty="0"/>
+          </a:p>
+        </p:txBody>
+      </p:sp>
+      <p:sp>
+        <p:nvSpPr>
+          <p:cNvPr id="4" name="Slide Number Placeholder 3"/>
+          <p:cNvSpPr>
+            <a:spLocks noGrp="1"/>
+          </p:cNvSpPr>
+          <p:nvPr>
+            <p:ph type="sldNum" sz="quarter" idx="10"/>
+          </p:nvPr>
+        </p:nvSpPr>
+        <p:spPr/>
+        <p:txBody>
+          <a:bodyPr/>
+          <a:lstStyle/>
+          <a:p>
+            <a:fld id="{F7021451-1387-4CA6-816F-3879F97B5CBC}" type="slidenum">
+              <a:rPr lang="en-US"/>
+              <a:t>11</a:t>
             </a:fld>
             <a:endParaRPr lang="en-US"/>
           </a:p>
@@ -1892,6 +2070,1995 @@
 </p:sld>
 </file>
 
+<file path=ppt/slides/slide10.xml><?xml version="1.0" encoding="utf-8"?>
+<p:sld xmlns:a="http://schemas.openxmlformats.org/drawingml/2006/main" xmlns:r="http://schemas.openxmlformats.org/officeDocument/2006/relationships" xmlns:p="http://schemas.openxmlformats.org/presentationml/2006/main">
+  <p:cSld name="Slide 10">
+    <p:bg>
+      <p:bgPr>
+        <a:solidFill>
+          <a:srgbClr val="FFFFFF"/>
+        </a:solidFill>
+      </p:bgPr>
+    </p:bg>
+    <p:spTree>
+      <p:nvGrpSpPr>
+        <p:cNvPr id="1" name=""/>
+        <p:cNvGrpSpPr/>
+        <p:nvPr/>
+      </p:nvGrpSpPr>
+      <p:grpSpPr>
+        <a:xfrm>
+          <a:off x="0" y="0"/>
+          <a:ext cx="0" cy="0"/>
+          <a:chOff x="0" y="0"/>
+          <a:chExt cx="0" cy="0"/>
+        </a:xfrm>
+      </p:grpSpPr>
+      <p:sp>
+        <p:nvSpPr>
+          <p:cNvPr id="2" name="Shape 0"/>
+          <p:cNvSpPr/>
+          <p:nvPr/>
+        </p:nvSpPr>
+        <p:spPr>
+          <a:xfrm>
+            <a:off x="365760" y="292608"/>
+            <a:ext cx="8412480" cy="0"/>
+          </a:xfrm>
+          <a:prstGeom prst="line">
+            <a:avLst/>
+          </a:prstGeom>
+          <a:noFill/>
+          <a:ln w="12700">
+            <a:solidFill>
+              <a:srgbClr val="111111"/>
+            </a:solidFill>
+            <a:prstDash val="solid"/>
+          </a:ln>
+        </p:spPr>
+      </p:sp>
+      <p:sp>
+        <p:nvSpPr>
+          <p:cNvPr id="3" name="Text 1"/>
+          <p:cNvSpPr/>
+          <p:nvPr/>
+        </p:nvSpPr>
+        <p:spPr>
+          <a:xfrm>
+            <a:off x="365760" y="347472"/>
+            <a:ext cx="731520" cy="201168"/>
+          </a:xfrm>
+          <a:prstGeom prst="rect">
+            <a:avLst/>
+          </a:prstGeom>
+          <a:noFill/>
+          <a:ln/>
+        </p:spPr>
+        <p:txBody>
+          <a:bodyPr wrap="square" lIns="0" tIns="0" rIns="0" bIns="0" rtlCol="0" anchor="ctr"/>
+          <a:lstStyle/>
+          <a:p>
+            <a:pPr algn="l" indent="0" marL="0">
+              <a:buNone/>
+            </a:pPr>
+            <a:r>
+              <a:rPr lang="en-US" sz="800" dirty="0">
+                <a:solidFill>
+                  <a:srgbClr val="AAAAAA"/>
+                </a:solidFill>
+                <a:latin typeface="Courier New" pitchFamily="34" charset="0"/>
+                <a:ea typeface="Courier New" pitchFamily="34" charset="-122"/>
+                <a:cs typeface="Courier New" pitchFamily="34" charset="-120"/>
+              </a:rPr>
+              <a:t>§ App.</a:t>
+            </a:r>
+            <a:endParaRPr lang="en-US" sz="800" dirty="0"/>
+          </a:p>
+        </p:txBody>
+      </p:sp>
+      <p:sp>
+        <p:nvSpPr>
+          <p:cNvPr id="4" name="Text 2"/>
+          <p:cNvSpPr/>
+          <p:nvPr/>
+        </p:nvSpPr>
+        <p:spPr>
+          <a:xfrm>
+            <a:off x="1051560" y="310896"/>
+            <a:ext cx="7726680" cy="292608"/>
+          </a:xfrm>
+          <a:prstGeom prst="rect">
+            <a:avLst/>
+          </a:prstGeom>
+          <a:noFill/>
+          <a:ln/>
+        </p:spPr>
+        <p:txBody>
+          <a:bodyPr wrap="square" lIns="0" tIns="0" rIns="0" bIns="0" rtlCol="0" anchor="ctr"/>
+          <a:lstStyle/>
+          <a:p>
+            <a:pPr algn="l" indent="0" marL="0">
+              <a:buNone/>
+            </a:pPr>
+            <a:r>
+              <a:rPr lang="en-US" sz="2000" b="1" dirty="0">
+                <a:solidFill>
+                  <a:srgbClr val="111111"/>
+                </a:solidFill>
+                <a:latin typeface="Times New Roman" pitchFamily="34" charset="0"/>
+                <a:ea typeface="Times New Roman" pitchFamily="34" charset="-122"/>
+                <a:cs typeface="Times New Roman" pitchFamily="34" charset="-120"/>
+              </a:rPr>
+              <a:t>Environnements mathématiques numérotés</a:t>
+            </a:r>
+            <a:endParaRPr lang="en-US" sz="2000" dirty="0"/>
+          </a:p>
+        </p:txBody>
+      </p:sp>
+      <p:sp>
+        <p:nvSpPr>
+          <p:cNvPr id="5" name="Shape 3"/>
+          <p:cNvSpPr/>
+          <p:nvPr/>
+        </p:nvSpPr>
+        <p:spPr>
+          <a:xfrm>
+            <a:off x="365760" y="658368"/>
+            <a:ext cx="8412480" cy="0"/>
+          </a:xfrm>
+          <a:prstGeom prst="line">
+            <a:avLst/>
+          </a:prstGeom>
+          <a:noFill/>
+          <a:ln w="6350">
+            <a:solidFill>
+              <a:srgbClr val="CCCCCC"/>
+            </a:solidFill>
+            <a:prstDash val="solid"/>
+          </a:ln>
+        </p:spPr>
+      </p:sp>
+      <p:sp>
+        <p:nvSpPr>
+          <p:cNvPr id="6" name="Text 4"/>
+          <p:cNvSpPr/>
+          <p:nvPr/>
+        </p:nvSpPr>
+        <p:spPr>
+          <a:xfrm>
+            <a:off x="365760" y="804672"/>
+            <a:ext cx="8412480" cy="384048"/>
+          </a:xfrm>
+          <a:prstGeom prst="rect">
+            <a:avLst/>
+          </a:prstGeom>
+          <a:noFill/>
+          <a:ln/>
+        </p:spPr>
+        <p:txBody>
+          <a:bodyPr wrap="square" lIns="0" tIns="0" rIns="0" bIns="0" rtlCol="0" anchor="ctr"/>
+          <a:lstStyle/>
+          <a:p>
+            <a:pPr algn="l" indent="0" marL="0">
+              <a:buNone/>
+            </a:pPr>
+            <a:r>
+              <a:rPr lang="en-US" sz="1100" i="1" dirty="0">
+                <a:solidFill>
+                  <a:srgbClr val="666666"/>
+                </a:solidFill>
+                <a:latin typeface="Times New Roman" pitchFamily="34" charset="0"/>
+                <a:ea typeface="Times New Roman" pitchFamily="34" charset="-122"/>
+                <a:cs typeface="Times New Roman" pitchFamily="34" charset="-120"/>
+              </a:rPr>
+              <a:t>Chaque environnement possède un style visuel distinct. Le compteur Définition / Théorème / Proposition / Lemme / Corollaire est partagé par section.</a:t>
+            </a:r>
+            <a:endParaRPr lang="en-US" sz="1100" dirty="0"/>
+          </a:p>
+        </p:txBody>
+      </p:sp>
+      <p:sp>
+        <p:nvSpPr>
+          <p:cNvPr id="7" name="Shape 5"/>
+          <p:cNvSpPr/>
+          <p:nvPr/>
+        </p:nvSpPr>
+        <p:spPr>
+          <a:xfrm>
+            <a:off x="365760" y="1280160"/>
+            <a:ext cx="3977640" cy="1207008"/>
+          </a:xfrm>
+          <a:prstGeom prst="rect">
+            <a:avLst/>
+          </a:prstGeom>
+          <a:solidFill>
+            <a:srgbClr val="F5F5F5"/>
+          </a:solidFill>
+          <a:ln w="5080">
+            <a:solidFill>
+              <a:srgbClr val="CCCCCC"/>
+            </a:solidFill>
+            <a:prstDash val="solid"/>
+          </a:ln>
+        </p:spPr>
+      </p:sp>
+      <p:sp>
+        <p:nvSpPr>
+          <p:cNvPr id="8" name="Text 6"/>
+          <p:cNvSpPr/>
+          <p:nvPr/>
+        </p:nvSpPr>
+        <p:spPr>
+          <a:xfrm>
+            <a:off x="457200" y="1335024"/>
+            <a:ext cx="3794760" cy="237744"/>
+          </a:xfrm>
+          <a:prstGeom prst="rect">
+            <a:avLst/>
+          </a:prstGeom>
+          <a:noFill/>
+          <a:ln/>
+        </p:spPr>
+        <p:txBody>
+          <a:bodyPr wrap="square" lIns="0" tIns="0" rIns="0" bIns="0" rtlCol="0" anchor="ctr"/>
+          <a:lstStyle/>
+          <a:p>
+            <a:pPr algn="l" indent="0" marL="0">
+              <a:buNone/>
+            </a:pPr>
+            <a:r>
+              <a:rPr lang="en-US" sz="1000" b="1" dirty="0">
+                <a:solidFill>
+                  <a:srgbClr val="111111"/>
+                </a:solidFill>
+                <a:latin typeface="Times New Roman" pitchFamily="34" charset="0"/>
+                <a:ea typeface="Times New Roman" pitchFamily="34" charset="-122"/>
+                <a:cs typeface="Times New Roman" pitchFamily="34" charset="-120"/>
+              </a:rPr>
+              <a:t>Définition 2.1</a:t>
+            </a:r>
+            <a:endParaRPr lang="en-US" sz="1000" dirty="0"/>
+          </a:p>
+        </p:txBody>
+      </p:sp>
+      <p:sp>
+        <p:nvSpPr>
+          <p:cNvPr id="9" name="Text 7"/>
+          <p:cNvSpPr/>
+          <p:nvPr/>
+        </p:nvSpPr>
+        <p:spPr>
+          <a:xfrm>
+            <a:off x="457200" y="1517904"/>
+            <a:ext cx="3794760" cy="146304"/>
+          </a:xfrm>
+          <a:prstGeom prst="rect">
+            <a:avLst/>
+          </a:prstGeom>
+          <a:noFill/>
+          <a:ln/>
+        </p:spPr>
+        <p:txBody>
+          <a:bodyPr wrap="square" lIns="0" tIns="0" rIns="0" bIns="0" rtlCol="0" anchor="ctr"/>
+          <a:lstStyle/>
+          <a:p>
+            <a:pPr algn="l" indent="0" marL="0">
+              <a:buNone/>
+            </a:pPr>
+            <a:r>
+              <a:rPr lang="en-US" sz="700" dirty="0">
+                <a:solidFill>
+                  <a:srgbClr val="AAAAAA"/>
+                </a:solidFill>
+                <a:latin typeface="Courier New" pitchFamily="34" charset="0"/>
+                <a:ea typeface="Courier New" pitchFamily="34" charset="-122"/>
+                <a:cs typeface="Courier New" pitchFamily="34" charset="-120"/>
+              </a:rPr>
+              <a:t>fond gris · compteur partagé</a:t>
+            </a:r>
+            <a:endParaRPr lang="en-US" sz="700" dirty="0"/>
+          </a:p>
+        </p:txBody>
+      </p:sp>
+      <p:sp>
+        <p:nvSpPr>
+          <p:cNvPr id="10" name="Text 8"/>
+          <p:cNvSpPr/>
+          <p:nvPr/>
+        </p:nvSpPr>
+        <p:spPr>
+          <a:xfrm>
+            <a:off x="457200" y="1682496"/>
+            <a:ext cx="3776472" cy="731520"/>
+          </a:xfrm>
+          <a:prstGeom prst="rect">
+            <a:avLst/>
+          </a:prstGeom>
+          <a:noFill/>
+          <a:ln/>
+        </p:spPr>
+        <p:txBody>
+          <a:bodyPr wrap="square" lIns="0" tIns="0" rIns="0" bIns="0" rtlCol="0" anchor="ctr"/>
+          <a:lstStyle/>
+          <a:p>
+            <a:pPr algn="l" indent="0" marL="0">
+              <a:buNone/>
+            </a:pPr>
+            <a:r>
+              <a:rPr lang="en-US" sz="1000" dirty="0">
+                <a:solidFill>
+                  <a:srgbClr val="333333"/>
+                </a:solidFill>
+                <a:latin typeface="Times New Roman" pitchFamily="34" charset="0"/>
+                <a:ea typeface="Times New Roman" pitchFamily="34" charset="-122"/>
+                <a:cs typeface="Times New Roman" pitchFamily="34" charset="-120"/>
+              </a:rPr>
+              <a:t>Un espace métrique (X, d) est complet si toute suite de Cauchy converge dans X.</a:t>
+            </a:r>
+            <a:endParaRPr lang="en-US" sz="1000" dirty="0"/>
+          </a:p>
+        </p:txBody>
+      </p:sp>
+      <p:sp>
+        <p:nvSpPr>
+          <p:cNvPr id="11" name="Shape 9"/>
+          <p:cNvSpPr/>
+          <p:nvPr/>
+        </p:nvSpPr>
+        <p:spPr>
+          <a:xfrm>
+            <a:off x="4434840" y="1280160"/>
+            <a:ext cx="3977640" cy="1207008"/>
+          </a:xfrm>
+          <a:prstGeom prst="rect">
+            <a:avLst/>
+          </a:prstGeom>
+          <a:solidFill>
+            <a:srgbClr val="F5F5F5"/>
+          </a:solidFill>
+          <a:ln w="5080">
+            <a:solidFill>
+              <a:srgbClr val="CCCCCC"/>
+            </a:solidFill>
+            <a:prstDash val="solid"/>
+          </a:ln>
+        </p:spPr>
+      </p:sp>
+      <p:sp>
+        <p:nvSpPr>
+          <p:cNvPr id="12" name="Text 10"/>
+          <p:cNvSpPr/>
+          <p:nvPr/>
+        </p:nvSpPr>
+        <p:spPr>
+          <a:xfrm>
+            <a:off x="4526280" y="1335024"/>
+            <a:ext cx="3794760" cy="237744"/>
+          </a:xfrm>
+          <a:prstGeom prst="rect">
+            <a:avLst/>
+          </a:prstGeom>
+          <a:noFill/>
+          <a:ln/>
+        </p:spPr>
+        <p:txBody>
+          <a:bodyPr wrap="square" lIns="0" tIns="0" rIns="0" bIns="0" rtlCol="0" anchor="ctr"/>
+          <a:lstStyle/>
+          <a:p>
+            <a:pPr algn="l" indent="0" marL="0">
+              <a:buNone/>
+            </a:pPr>
+            <a:r>
+              <a:rPr lang="en-US" sz="1000" b="1" dirty="0">
+                <a:solidFill>
+                  <a:srgbClr val="111111"/>
+                </a:solidFill>
+                <a:latin typeface="Times New Roman" pitchFamily="34" charset="0"/>
+                <a:ea typeface="Times New Roman" pitchFamily="34" charset="-122"/>
+                <a:cs typeface="Times New Roman" pitchFamily="34" charset="-120"/>
+              </a:rPr>
+              <a:t>Théorème 2.2</a:t>
+            </a:r>
+            <a:endParaRPr lang="en-US" sz="1000" dirty="0"/>
+          </a:p>
+        </p:txBody>
+      </p:sp>
+      <p:sp>
+        <p:nvSpPr>
+          <p:cNvPr id="13" name="Text 11"/>
+          <p:cNvSpPr/>
+          <p:nvPr/>
+        </p:nvSpPr>
+        <p:spPr>
+          <a:xfrm>
+            <a:off x="4526280" y="1517904"/>
+            <a:ext cx="3794760" cy="146304"/>
+          </a:xfrm>
+          <a:prstGeom prst="rect">
+            <a:avLst/>
+          </a:prstGeom>
+          <a:noFill/>
+          <a:ln/>
+        </p:spPr>
+        <p:txBody>
+          <a:bodyPr wrap="square" lIns="0" tIns="0" rIns="0" bIns="0" rtlCol="0" anchor="ctr"/>
+          <a:lstStyle/>
+          <a:p>
+            <a:pPr algn="l" indent="0" marL="0">
+              <a:buNone/>
+            </a:pPr>
+            <a:r>
+              <a:rPr lang="en-US" sz="700" dirty="0">
+                <a:solidFill>
+                  <a:srgbClr val="AAAAAA"/>
+                </a:solidFill>
+                <a:latin typeface="Courier New" pitchFamily="34" charset="0"/>
+                <a:ea typeface="Courier New" pitchFamily="34" charset="-122"/>
+                <a:cs typeface="Courier New" pitchFamily="34" charset="-120"/>
+              </a:rPr>
+              <a:t>fond gris · énoncé principal</a:t>
+            </a:r>
+            <a:endParaRPr lang="en-US" sz="700" dirty="0"/>
+          </a:p>
+        </p:txBody>
+      </p:sp>
+      <p:sp>
+        <p:nvSpPr>
+          <p:cNvPr id="14" name="Text 12"/>
+          <p:cNvSpPr/>
+          <p:nvPr/>
+        </p:nvSpPr>
+        <p:spPr>
+          <a:xfrm>
+            <a:off x="4526280" y="1682496"/>
+            <a:ext cx="3776472" cy="731520"/>
+          </a:xfrm>
+          <a:prstGeom prst="rect">
+            <a:avLst/>
+          </a:prstGeom>
+          <a:noFill/>
+          <a:ln/>
+        </p:spPr>
+        <p:txBody>
+          <a:bodyPr wrap="square" lIns="0" tIns="0" rIns="0" bIns="0" rtlCol="0" anchor="ctr"/>
+          <a:lstStyle/>
+          <a:p>
+            <a:pPr algn="l" indent="0" marL="0">
+              <a:buNone/>
+            </a:pPr>
+            <a:r>
+              <a:rPr lang="en-US" sz="1000" dirty="0">
+                <a:solidFill>
+                  <a:srgbClr val="333333"/>
+                </a:solidFill>
+                <a:latin typeface="Times New Roman" pitchFamily="34" charset="0"/>
+                <a:ea typeface="Times New Roman" pitchFamily="34" charset="-122"/>
+                <a:cs typeface="Times New Roman" pitchFamily="34" charset="-120"/>
+              </a:rPr>
+              <a:t>Tout algorithme de tri par comparaison requiert Ω(n log n) comparaisons.</a:t>
+            </a:r>
+            <a:endParaRPr lang="en-US" sz="1000" dirty="0"/>
+          </a:p>
+        </p:txBody>
+      </p:sp>
+      <p:sp>
+        <p:nvSpPr>
+          <p:cNvPr id="15" name="Shape 13"/>
+          <p:cNvSpPr/>
+          <p:nvPr/>
+        </p:nvSpPr>
+        <p:spPr>
+          <a:xfrm>
+            <a:off x="365760" y="2615184"/>
+            <a:ext cx="3977640" cy="1207008"/>
+          </a:xfrm>
+          <a:prstGeom prst="rect">
+            <a:avLst/>
+          </a:prstGeom>
+          <a:solidFill>
+            <a:srgbClr val="F5F5F5"/>
+          </a:solidFill>
+          <a:ln w="5080">
+            <a:solidFill>
+              <a:srgbClr val="CCCCCC"/>
+            </a:solidFill>
+            <a:prstDash val="solid"/>
+          </a:ln>
+        </p:spPr>
+      </p:sp>
+      <p:sp>
+        <p:nvSpPr>
+          <p:cNvPr id="16" name="Text 14"/>
+          <p:cNvSpPr/>
+          <p:nvPr/>
+        </p:nvSpPr>
+        <p:spPr>
+          <a:xfrm>
+            <a:off x="457200" y="2670048"/>
+            <a:ext cx="3794760" cy="237744"/>
+          </a:xfrm>
+          <a:prstGeom prst="rect">
+            <a:avLst/>
+          </a:prstGeom>
+          <a:noFill/>
+          <a:ln/>
+        </p:spPr>
+        <p:txBody>
+          <a:bodyPr wrap="square" lIns="0" tIns="0" rIns="0" bIns="0" rtlCol="0" anchor="ctr"/>
+          <a:lstStyle/>
+          <a:p>
+            <a:pPr algn="l" indent="0" marL="0">
+              <a:buNone/>
+            </a:pPr>
+            <a:r>
+              <a:rPr lang="en-US" sz="1000" b="1" dirty="0">
+                <a:solidFill>
+                  <a:srgbClr val="111111"/>
+                </a:solidFill>
+                <a:latin typeface="Times New Roman" pitchFamily="34" charset="0"/>
+                <a:ea typeface="Times New Roman" pitchFamily="34" charset="-122"/>
+                <a:cs typeface="Times New Roman" pitchFamily="34" charset="-120"/>
+              </a:rPr>
+              <a:t>Proposition 2.3</a:t>
+            </a:r>
+            <a:endParaRPr lang="en-US" sz="1000" dirty="0"/>
+          </a:p>
+        </p:txBody>
+      </p:sp>
+      <p:sp>
+        <p:nvSpPr>
+          <p:cNvPr id="17" name="Text 15"/>
+          <p:cNvSpPr/>
+          <p:nvPr/>
+        </p:nvSpPr>
+        <p:spPr>
+          <a:xfrm>
+            <a:off x="457200" y="2852928"/>
+            <a:ext cx="3794760" cy="146304"/>
+          </a:xfrm>
+          <a:prstGeom prst="rect">
+            <a:avLst/>
+          </a:prstGeom>
+          <a:noFill/>
+          <a:ln/>
+        </p:spPr>
+        <p:txBody>
+          <a:bodyPr wrap="square" lIns="0" tIns="0" rIns="0" bIns="0" rtlCol="0" anchor="ctr"/>
+          <a:lstStyle/>
+          <a:p>
+            <a:pPr algn="l" indent="0" marL="0">
+              <a:buNone/>
+            </a:pPr>
+            <a:r>
+              <a:rPr lang="en-US" sz="700" dirty="0">
+                <a:solidFill>
+                  <a:srgbClr val="AAAAAA"/>
+                </a:solidFill>
+                <a:latin typeface="Courier New" pitchFamily="34" charset="0"/>
+                <a:ea typeface="Courier New" pitchFamily="34" charset="-122"/>
+                <a:cs typeface="Courier New" pitchFamily="34" charset="-120"/>
+              </a:rPr>
+              <a:t>fond gris · résultat intermédiaire</a:t>
+            </a:r>
+            <a:endParaRPr lang="en-US" sz="700" dirty="0"/>
+          </a:p>
+        </p:txBody>
+      </p:sp>
+      <p:sp>
+        <p:nvSpPr>
+          <p:cNvPr id="18" name="Text 16"/>
+          <p:cNvSpPr/>
+          <p:nvPr/>
+        </p:nvSpPr>
+        <p:spPr>
+          <a:xfrm>
+            <a:off x="457200" y="3017520"/>
+            <a:ext cx="3776472" cy="731520"/>
+          </a:xfrm>
+          <a:prstGeom prst="rect">
+            <a:avLst/>
+          </a:prstGeom>
+          <a:noFill/>
+          <a:ln/>
+        </p:spPr>
+        <p:txBody>
+          <a:bodyPr wrap="square" lIns="0" tIns="0" rIns="0" bIns="0" rtlCol="0" anchor="ctr"/>
+          <a:lstStyle/>
+          <a:p>
+            <a:pPr algn="l" indent="0" marL="0">
+              <a:buNone/>
+            </a:pPr>
+            <a:r>
+              <a:rPr lang="en-US" sz="1000" dirty="0">
+                <a:solidFill>
+                  <a:srgbClr val="333333"/>
+                </a:solidFill>
+                <a:latin typeface="Times New Roman" pitchFamily="34" charset="0"/>
+                <a:ea typeface="Times New Roman" pitchFamily="34" charset="-122"/>
+                <a:cs typeface="Times New Roman" pitchFamily="34" charset="-120"/>
+              </a:rPr>
+              <a:t>Si (uₙ) converge, elle est de Cauchy. La réciproque est vraie dans ℝ.</a:t>
+            </a:r>
+            <a:endParaRPr lang="en-US" sz="1000" dirty="0"/>
+          </a:p>
+        </p:txBody>
+      </p:sp>
+      <p:sp>
+        <p:nvSpPr>
+          <p:cNvPr id="19" name="Shape 17"/>
+          <p:cNvSpPr/>
+          <p:nvPr/>
+        </p:nvSpPr>
+        <p:spPr>
+          <a:xfrm>
+            <a:off x="4434840" y="2615184"/>
+            <a:ext cx="3977640" cy="1207008"/>
+          </a:xfrm>
+          <a:prstGeom prst="rect">
+            <a:avLst/>
+          </a:prstGeom>
+          <a:solidFill>
+            <a:srgbClr val="FFFFFF"/>
+          </a:solidFill>
+          <a:ln w="5080">
+            <a:solidFill>
+              <a:srgbClr val="FFFFFF"/>
+            </a:solidFill>
+            <a:prstDash val="solid"/>
+          </a:ln>
+        </p:spPr>
+      </p:sp>
+      <p:sp>
+        <p:nvSpPr>
+          <p:cNvPr id="20" name="Shape 18"/>
+          <p:cNvSpPr/>
+          <p:nvPr/>
+        </p:nvSpPr>
+        <p:spPr>
+          <a:xfrm>
+            <a:off x="4434840" y="2615184"/>
+            <a:ext cx="45720" cy="1207008"/>
+          </a:xfrm>
+          <a:prstGeom prst="rect">
+            <a:avLst/>
+          </a:prstGeom>
+          <a:solidFill>
+            <a:srgbClr val="CCCCCC"/>
+          </a:solidFill>
+          <a:ln w="12700">
+            <a:solidFill>
+              <a:srgbClr val="CCCCCC"/>
+            </a:solidFill>
+            <a:prstDash val="solid"/>
+          </a:ln>
+        </p:spPr>
+      </p:sp>
+      <p:sp>
+        <p:nvSpPr>
+          <p:cNvPr id="21" name="Text 19"/>
+          <p:cNvSpPr/>
+          <p:nvPr/>
+        </p:nvSpPr>
+        <p:spPr>
+          <a:xfrm>
+            <a:off x="4562856" y="2670048"/>
+            <a:ext cx="3794760" cy="237744"/>
+          </a:xfrm>
+          <a:prstGeom prst="rect">
+            <a:avLst/>
+          </a:prstGeom>
+          <a:noFill/>
+          <a:ln/>
+        </p:spPr>
+        <p:txBody>
+          <a:bodyPr wrap="square" lIns="0" tIns="0" rIns="0" bIns="0" rtlCol="0" anchor="ctr"/>
+          <a:lstStyle/>
+          <a:p>
+            <a:pPr algn="l" indent="0" marL="0">
+              <a:buNone/>
+            </a:pPr>
+            <a:r>
+              <a:rPr lang="en-US" sz="1000" b="1" dirty="0">
+                <a:solidFill>
+                  <a:srgbClr val="111111"/>
+                </a:solidFill>
+                <a:latin typeface="Times New Roman" pitchFamily="34" charset="0"/>
+                <a:ea typeface="Times New Roman" pitchFamily="34" charset="-122"/>
+                <a:cs typeface="Times New Roman" pitchFamily="34" charset="-120"/>
+              </a:rPr>
+              <a:t>Exemple 2.1</a:t>
+            </a:r>
+            <a:endParaRPr lang="en-US" sz="1000" dirty="0"/>
+          </a:p>
+        </p:txBody>
+      </p:sp>
+      <p:sp>
+        <p:nvSpPr>
+          <p:cNvPr id="22" name="Text 20"/>
+          <p:cNvSpPr/>
+          <p:nvPr/>
+        </p:nvSpPr>
+        <p:spPr>
+          <a:xfrm>
+            <a:off x="4562856" y="2852928"/>
+            <a:ext cx="3794760" cy="146304"/>
+          </a:xfrm>
+          <a:prstGeom prst="rect">
+            <a:avLst/>
+          </a:prstGeom>
+          <a:noFill/>
+          <a:ln/>
+        </p:spPr>
+        <p:txBody>
+          <a:bodyPr wrap="square" lIns="0" tIns="0" rIns="0" bIns="0" rtlCol="0" anchor="ctr"/>
+          <a:lstStyle/>
+          <a:p>
+            <a:pPr algn="l" indent="0" marL="0">
+              <a:buNone/>
+            </a:pPr>
+            <a:r>
+              <a:rPr lang="en-US" sz="700" dirty="0">
+                <a:solidFill>
+                  <a:srgbClr val="AAAAAA"/>
+                </a:solidFill>
+                <a:latin typeface="Courier New" pitchFamily="34" charset="0"/>
+                <a:ea typeface="Courier New" pitchFamily="34" charset="-122"/>
+                <a:cs typeface="Courier New" pitchFamily="34" charset="-120"/>
+              </a:rPr>
+              <a:t>trait gauche · illustration</a:t>
+            </a:r>
+            <a:endParaRPr lang="en-US" sz="700" dirty="0"/>
+          </a:p>
+        </p:txBody>
+      </p:sp>
+      <p:sp>
+        <p:nvSpPr>
+          <p:cNvPr id="23" name="Text 21"/>
+          <p:cNvSpPr/>
+          <p:nvPr/>
+        </p:nvSpPr>
+        <p:spPr>
+          <a:xfrm>
+            <a:off x="4562856" y="3017520"/>
+            <a:ext cx="3776472" cy="731520"/>
+          </a:xfrm>
+          <a:prstGeom prst="rect">
+            <a:avLst/>
+          </a:prstGeom>
+          <a:noFill/>
+          <a:ln/>
+        </p:spPr>
+        <p:txBody>
+          <a:bodyPr wrap="square" lIns="0" tIns="0" rIns="0" bIns="0" rtlCol="0" anchor="ctr"/>
+          <a:lstStyle/>
+          <a:p>
+            <a:pPr algn="l" indent="0" marL="0">
+              <a:buNone/>
+            </a:pPr>
+            <a:r>
+              <a:rPr lang="en-US" sz="1000" dirty="0">
+                <a:solidFill>
+                  <a:srgbClr val="333333"/>
+                </a:solidFill>
+                <a:latin typeface="Times New Roman" pitchFamily="34" charset="0"/>
+                <a:ea typeface="Times New Roman" pitchFamily="34" charset="-122"/>
+                <a:cs typeface="Times New Roman" pitchFamily="34" charset="-120"/>
+              </a:rPr>
+              <a:t>La suite uₙ = rⁿ converge vers 0 si |r| &lt; 1 et diverge sinon.</a:t>
+            </a:r>
+            <a:endParaRPr lang="en-US" sz="1000" dirty="0"/>
+          </a:p>
+        </p:txBody>
+      </p:sp>
+      <p:sp>
+        <p:nvSpPr>
+          <p:cNvPr id="24" name="Shape 22"/>
+          <p:cNvSpPr/>
+          <p:nvPr/>
+        </p:nvSpPr>
+        <p:spPr>
+          <a:xfrm>
+            <a:off x="365760" y="3950208"/>
+            <a:ext cx="3977640" cy="1207008"/>
+          </a:xfrm>
+          <a:prstGeom prst="rect">
+            <a:avLst/>
+          </a:prstGeom>
+          <a:solidFill>
+            <a:srgbClr val="FFFFFF"/>
+          </a:solidFill>
+          <a:ln w="10160">
+            <a:solidFill>
+              <a:srgbClr val="111111"/>
+            </a:solidFill>
+            <a:prstDash val="solid"/>
+          </a:ln>
+        </p:spPr>
+      </p:sp>
+      <p:sp>
+        <p:nvSpPr>
+          <p:cNvPr id="25" name="Text 23"/>
+          <p:cNvSpPr/>
+          <p:nvPr/>
+        </p:nvSpPr>
+        <p:spPr>
+          <a:xfrm>
+            <a:off x="457200" y="4005072"/>
+            <a:ext cx="3794760" cy="237744"/>
+          </a:xfrm>
+          <a:prstGeom prst="rect">
+            <a:avLst/>
+          </a:prstGeom>
+          <a:noFill/>
+          <a:ln/>
+        </p:spPr>
+        <p:txBody>
+          <a:bodyPr wrap="square" lIns="0" tIns="0" rIns="0" bIns="0" rtlCol="0" anchor="ctr"/>
+          <a:lstStyle/>
+          <a:p>
+            <a:pPr algn="l" indent="0" marL="0">
+              <a:buNone/>
+            </a:pPr>
+            <a:r>
+              <a:rPr lang="en-US" sz="1000" b="1" dirty="0">
+                <a:solidFill>
+                  <a:srgbClr val="111111"/>
+                </a:solidFill>
+                <a:latin typeface="Times New Roman" pitchFamily="34" charset="0"/>
+                <a:ea typeface="Times New Roman" pitchFamily="34" charset="-122"/>
+                <a:cs typeface="Times New Roman" pitchFamily="34" charset="-120"/>
+              </a:rPr>
+              <a:t>Exercice 3.1</a:t>
+            </a:r>
+            <a:endParaRPr lang="en-US" sz="1000" dirty="0"/>
+          </a:p>
+        </p:txBody>
+      </p:sp>
+      <p:sp>
+        <p:nvSpPr>
+          <p:cNvPr id="26" name="Text 24"/>
+          <p:cNvSpPr/>
+          <p:nvPr/>
+        </p:nvSpPr>
+        <p:spPr>
+          <a:xfrm>
+            <a:off x="457200" y="4187952"/>
+            <a:ext cx="3794760" cy="146304"/>
+          </a:xfrm>
+          <a:prstGeom prst="rect">
+            <a:avLst/>
+          </a:prstGeom>
+          <a:noFill/>
+          <a:ln/>
+        </p:spPr>
+        <p:txBody>
+          <a:bodyPr wrap="square" lIns="0" tIns="0" rIns="0" bIns="0" rtlCol="0" anchor="ctr"/>
+          <a:lstStyle/>
+          <a:p>
+            <a:pPr algn="l" indent="0" marL="0">
+              <a:buNone/>
+            </a:pPr>
+            <a:r>
+              <a:rPr lang="en-US" sz="700" dirty="0">
+                <a:solidFill>
+                  <a:srgbClr val="AAAAAA"/>
+                </a:solidFill>
+                <a:latin typeface="Courier New" pitchFamily="34" charset="0"/>
+                <a:ea typeface="Courier New" pitchFamily="34" charset="-122"/>
+                <a:cs typeface="Courier New" pitchFamily="34" charset="-120"/>
+              </a:rPr>
+              <a:t>cadre fin · à résoudre</a:t>
+            </a:r>
+            <a:endParaRPr lang="en-US" sz="700" dirty="0"/>
+          </a:p>
+        </p:txBody>
+      </p:sp>
+      <p:sp>
+        <p:nvSpPr>
+          <p:cNvPr id="27" name="Text 25"/>
+          <p:cNvSpPr/>
+          <p:nvPr/>
+        </p:nvSpPr>
+        <p:spPr>
+          <a:xfrm>
+            <a:off x="457200" y="4352544"/>
+            <a:ext cx="3776472" cy="731520"/>
+          </a:xfrm>
+          <a:prstGeom prst="rect">
+            <a:avLst/>
+          </a:prstGeom>
+          <a:noFill/>
+          <a:ln/>
+        </p:spPr>
+        <p:txBody>
+          <a:bodyPr wrap="square" lIns="0" tIns="0" rIns="0" bIns="0" rtlCol="0" anchor="ctr"/>
+          <a:lstStyle/>
+          <a:p>
+            <a:pPr algn="l" indent="0" marL="0">
+              <a:buNone/>
+            </a:pPr>
+            <a:r>
+              <a:rPr lang="en-US" sz="1000" dirty="0">
+                <a:solidFill>
+                  <a:srgbClr val="333333"/>
+                </a:solidFill>
+                <a:latin typeface="Times New Roman" pitchFamily="34" charset="0"/>
+                <a:ea typeface="Times New Roman" pitchFamily="34" charset="-122"/>
+                <a:cs typeface="Times New Roman" pitchFamily="34" charset="-120"/>
+              </a:rPr>
+              <a:t>Montrer que fₙ(x) = x/(1+nx²) converge uniformément vers 0 sur ℝ.</a:t>
+            </a:r>
+            <a:endParaRPr lang="en-US" sz="1000" dirty="0"/>
+          </a:p>
+        </p:txBody>
+      </p:sp>
+      <p:sp>
+        <p:nvSpPr>
+          <p:cNvPr id="28" name="Shape 26"/>
+          <p:cNvSpPr/>
+          <p:nvPr/>
+        </p:nvSpPr>
+        <p:spPr>
+          <a:xfrm>
+            <a:off x="4434840" y="3950208"/>
+            <a:ext cx="3977640" cy="1207008"/>
+          </a:xfrm>
+          <a:prstGeom prst="rect">
+            <a:avLst/>
+          </a:prstGeom>
+          <a:solidFill>
+            <a:srgbClr val="FFFFFF"/>
+          </a:solidFill>
+          <a:ln w="5080">
+            <a:solidFill>
+              <a:srgbClr val="FFFFFF"/>
+            </a:solidFill>
+            <a:prstDash val="solid"/>
+          </a:ln>
+        </p:spPr>
+      </p:sp>
+      <p:sp>
+        <p:nvSpPr>
+          <p:cNvPr id="29" name="Shape 27"/>
+          <p:cNvSpPr/>
+          <p:nvPr/>
+        </p:nvSpPr>
+        <p:spPr>
+          <a:xfrm>
+            <a:off x="4434840" y="3950208"/>
+            <a:ext cx="45720" cy="1207008"/>
+          </a:xfrm>
+          <a:prstGeom prst="rect">
+            <a:avLst/>
+          </a:prstGeom>
+          <a:solidFill>
+            <a:srgbClr val="CCCCCC"/>
+          </a:solidFill>
+          <a:ln w="12700">
+            <a:solidFill>
+              <a:srgbClr val="CCCCCC"/>
+            </a:solidFill>
+            <a:prstDash val="solid"/>
+          </a:ln>
+        </p:spPr>
+      </p:sp>
+      <p:sp>
+        <p:nvSpPr>
+          <p:cNvPr id="30" name="Text 28"/>
+          <p:cNvSpPr/>
+          <p:nvPr/>
+        </p:nvSpPr>
+        <p:spPr>
+          <a:xfrm>
+            <a:off x="4562856" y="4005072"/>
+            <a:ext cx="3794760" cy="237744"/>
+          </a:xfrm>
+          <a:prstGeom prst="rect">
+            <a:avLst/>
+          </a:prstGeom>
+          <a:noFill/>
+          <a:ln/>
+        </p:spPr>
+        <p:txBody>
+          <a:bodyPr wrap="square" lIns="0" tIns="0" rIns="0" bIns="0" rtlCol="0" anchor="ctr"/>
+          <a:lstStyle/>
+          <a:p>
+            <a:pPr algn="l" indent="0" marL="0">
+              <a:buNone/>
+            </a:pPr>
+            <a:r>
+              <a:rPr lang="en-US" sz="1000" b="1" dirty="0">
+                <a:solidFill>
+                  <a:srgbClr val="111111"/>
+                </a:solidFill>
+                <a:latin typeface="Times New Roman" pitchFamily="34" charset="0"/>
+                <a:ea typeface="Times New Roman" pitchFamily="34" charset="-122"/>
+                <a:cs typeface="Times New Roman" pitchFamily="34" charset="-120"/>
+              </a:rPr>
+              <a:t>Correction 3.1</a:t>
+            </a:r>
+            <a:endParaRPr lang="en-US" sz="1000" dirty="0"/>
+          </a:p>
+        </p:txBody>
+      </p:sp>
+      <p:sp>
+        <p:nvSpPr>
+          <p:cNvPr id="31" name="Text 29"/>
+          <p:cNvSpPr/>
+          <p:nvPr/>
+        </p:nvSpPr>
+        <p:spPr>
+          <a:xfrm>
+            <a:off x="4562856" y="4187952"/>
+            <a:ext cx="3794760" cy="146304"/>
+          </a:xfrm>
+          <a:prstGeom prst="rect">
+            <a:avLst/>
+          </a:prstGeom>
+          <a:noFill/>
+          <a:ln/>
+        </p:spPr>
+        <p:txBody>
+          <a:bodyPr wrap="square" lIns="0" tIns="0" rIns="0" bIns="0" rtlCol="0" anchor="ctr"/>
+          <a:lstStyle/>
+          <a:p>
+            <a:pPr algn="l" indent="0" marL="0">
+              <a:buNone/>
+            </a:pPr>
+            <a:r>
+              <a:rPr lang="en-US" sz="700" dirty="0">
+                <a:solidFill>
+                  <a:srgbClr val="AAAAAA"/>
+                </a:solidFill>
+                <a:latin typeface="Courier New" pitchFamily="34" charset="0"/>
+                <a:ea typeface="Courier New" pitchFamily="34" charset="-122"/>
+                <a:cs typeface="Courier New" pitchFamily="34" charset="-120"/>
+              </a:rPr>
+              <a:t>trait gauche italique</a:t>
+            </a:r>
+            <a:endParaRPr lang="en-US" sz="700" dirty="0"/>
+          </a:p>
+        </p:txBody>
+      </p:sp>
+      <p:sp>
+        <p:nvSpPr>
+          <p:cNvPr id="32" name="Text 30"/>
+          <p:cNvSpPr/>
+          <p:nvPr/>
+        </p:nvSpPr>
+        <p:spPr>
+          <a:xfrm>
+            <a:off x="4562856" y="4352544"/>
+            <a:ext cx="3776472" cy="731520"/>
+          </a:xfrm>
+          <a:prstGeom prst="rect">
+            <a:avLst/>
+          </a:prstGeom>
+          <a:noFill/>
+          <a:ln/>
+        </p:spPr>
+        <p:txBody>
+          <a:bodyPr wrap="square" lIns="0" tIns="0" rIns="0" bIns="0" rtlCol="0" anchor="ctr"/>
+          <a:lstStyle/>
+          <a:p>
+            <a:pPr algn="l" indent="0" marL="0">
+              <a:buNone/>
+            </a:pPr>
+            <a:r>
+              <a:rPr lang="en-US" sz="1000" i="1" dirty="0">
+                <a:solidFill>
+                  <a:srgbClr val="333333"/>
+                </a:solidFill>
+                <a:latin typeface="Times New Roman" pitchFamily="34" charset="0"/>
+                <a:ea typeface="Times New Roman" pitchFamily="34" charset="-122"/>
+                <a:cs typeface="Times New Roman" pitchFamily="34" charset="-120"/>
+              </a:rPr>
+              <a:t>Par AM-GM : 1+nx² ≥ 2√n|x|, donc |fₙ(x)| ≤ 1/(2√n) → 0.  ◆</a:t>
+            </a:r>
+            <a:endParaRPr lang="en-US" sz="1000" dirty="0"/>
+          </a:p>
+        </p:txBody>
+      </p:sp>
+      <p:sp>
+        <p:nvSpPr>
+          <p:cNvPr id="33" name="Shape 31"/>
+          <p:cNvSpPr/>
+          <p:nvPr/>
+        </p:nvSpPr>
+        <p:spPr>
+          <a:xfrm>
+            <a:off x="365760" y="4892040"/>
+            <a:ext cx="8412480" cy="0"/>
+          </a:xfrm>
+          <a:prstGeom prst="line">
+            <a:avLst/>
+          </a:prstGeom>
+          <a:noFill/>
+          <a:ln w="5080">
+            <a:solidFill>
+              <a:srgbClr val="CCCCCC"/>
+            </a:solidFill>
+            <a:prstDash val="solid"/>
+          </a:ln>
+        </p:spPr>
+      </p:sp>
+      <p:sp>
+        <p:nvSpPr>
+          <p:cNvPr id="34" name="Text 32"/>
+          <p:cNvSpPr/>
+          <p:nvPr/>
+        </p:nvSpPr>
+        <p:spPr>
+          <a:xfrm>
+            <a:off x="7772400" y="4919472"/>
+            <a:ext cx="1005840" cy="164592"/>
+          </a:xfrm>
+          <a:prstGeom prst="rect">
+            <a:avLst/>
+          </a:prstGeom>
+          <a:noFill/>
+          <a:ln/>
+        </p:spPr>
+        <p:txBody>
+          <a:bodyPr wrap="square" lIns="0" tIns="0" rIns="0" bIns="0" rtlCol="0" anchor="ctr"/>
+          <a:lstStyle/>
+          <a:p>
+            <a:pPr algn="r" indent="0" marL="0">
+              <a:buNone/>
+            </a:pPr>
+            <a:r>
+              <a:rPr lang="en-US" sz="800" dirty="0">
+                <a:solidFill>
+                  <a:srgbClr val="AAAAAA"/>
+                </a:solidFill>
+                <a:latin typeface="Courier New" pitchFamily="34" charset="0"/>
+                <a:ea typeface="Courier New" pitchFamily="34" charset="-122"/>
+                <a:cs typeface="Courier New" pitchFamily="34" charset="-120"/>
+              </a:rPr>
+              <a:t>10 / 11</a:t>
+            </a:r>
+            <a:endParaRPr lang="en-US" sz="800" dirty="0"/>
+          </a:p>
+        </p:txBody>
+      </p:sp>
+      <p:sp>
+        <p:nvSpPr>
+          <p:cNvPr id="35" name="Text 33"/>
+          <p:cNvSpPr/>
+          <p:nvPr/>
+        </p:nvSpPr>
+        <p:spPr>
+          <a:xfrm>
+            <a:off x="365760" y="4919472"/>
+            <a:ext cx="2743200" cy="164592"/>
+          </a:xfrm>
+          <a:prstGeom prst="rect">
+            <a:avLst/>
+          </a:prstGeom>
+          <a:noFill/>
+          <a:ln/>
+        </p:spPr>
+        <p:txBody>
+          <a:bodyPr wrap="square" lIns="0" tIns="0" rIns="0" bIns="0" rtlCol="0" anchor="ctr"/>
+          <a:lstStyle/>
+          <a:p>
+            <a:pPr algn="l" indent="0" marL="0">
+              <a:buNone/>
+            </a:pPr>
+            <a:r>
+              <a:rPr lang="en-US" sz="800" i="1" dirty="0">
+                <a:solidFill>
+                  <a:srgbClr val="AAAAAA"/>
+                </a:solidFill>
+                <a:latin typeface="Times New Roman" pitchFamily="34" charset="0"/>
+                <a:ea typeface="Times New Roman" pitchFamily="34" charset="-122"/>
+                <a:cs typeface="Times New Roman" pitchFamily="34" charset="-120"/>
+              </a:rPr>
+              <a:t>Ars Typographica</a:t>
+            </a:r>
+            <a:endParaRPr lang="en-US" sz="800" dirty="0"/>
+          </a:p>
+        </p:txBody>
+      </p:sp>
+    </p:spTree>
+  </p:cSld>
+  <p:clrMapOvr>
+    <a:masterClrMapping/>
+  </p:clrMapOvr>
+</p:sld>
+</file>
+
+<file path=ppt/slides/slide11.xml><?xml version="1.0" encoding="utf-8"?>
+<p:sld xmlns:a="http://schemas.openxmlformats.org/drawingml/2006/main" xmlns:r="http://schemas.openxmlformats.org/officeDocument/2006/relationships" xmlns:p="http://schemas.openxmlformats.org/presentationml/2006/main">
+  <p:cSld name="Slide 11">
+    <p:bg>
+      <p:bgPr>
+        <a:solidFill>
+          <a:srgbClr val="FFFFFF"/>
+        </a:solidFill>
+      </p:bgPr>
+    </p:bg>
+    <p:spTree>
+      <p:nvGrpSpPr>
+        <p:cNvPr id="1" name=""/>
+        <p:cNvGrpSpPr/>
+        <p:nvPr/>
+      </p:nvGrpSpPr>
+      <p:grpSpPr>
+        <a:xfrm>
+          <a:off x="0" y="0"/>
+          <a:ext cx="0" cy="0"/>
+          <a:chOff x="0" y="0"/>
+          <a:chExt cx="0" cy="0"/>
+        </a:xfrm>
+      </p:grpSpPr>
+      <p:sp>
+        <p:nvSpPr>
+          <p:cNvPr id="2" name="Shape 0"/>
+          <p:cNvSpPr/>
+          <p:nvPr/>
+        </p:nvSpPr>
+        <p:spPr>
+          <a:xfrm>
+            <a:off x="365760" y="292608"/>
+            <a:ext cx="8412480" cy="0"/>
+          </a:xfrm>
+          <a:prstGeom prst="line">
+            <a:avLst/>
+          </a:prstGeom>
+          <a:noFill/>
+          <a:ln w="12700">
+            <a:solidFill>
+              <a:srgbClr val="111111"/>
+            </a:solidFill>
+            <a:prstDash val="solid"/>
+          </a:ln>
+        </p:spPr>
+      </p:sp>
+      <p:sp>
+        <p:nvSpPr>
+          <p:cNvPr id="3" name="Text 1"/>
+          <p:cNvSpPr/>
+          <p:nvPr/>
+        </p:nvSpPr>
+        <p:spPr>
+          <a:xfrm>
+            <a:off x="365760" y="347472"/>
+            <a:ext cx="731520" cy="201168"/>
+          </a:xfrm>
+          <a:prstGeom prst="rect">
+            <a:avLst/>
+          </a:prstGeom>
+          <a:noFill/>
+          <a:ln/>
+        </p:spPr>
+        <p:txBody>
+          <a:bodyPr wrap="square" lIns="0" tIns="0" rIns="0" bIns="0" rtlCol="0" anchor="ctr"/>
+          <a:lstStyle/>
+          <a:p>
+            <a:pPr algn="l" indent="0" marL="0">
+              <a:buNone/>
+            </a:pPr>
+            <a:r>
+              <a:rPr lang="en-US" sz="800" dirty="0">
+                <a:solidFill>
+                  <a:srgbClr val="AAAAAA"/>
+                </a:solidFill>
+                <a:latin typeface="Courier New" pitchFamily="34" charset="0"/>
+                <a:ea typeface="Courier New" pitchFamily="34" charset="-122"/>
+                <a:cs typeface="Courier New" pitchFamily="34" charset="-120"/>
+              </a:rPr>
+              <a:t>§ App.</a:t>
+            </a:r>
+            <a:endParaRPr lang="en-US" sz="800" dirty="0"/>
+          </a:p>
+        </p:txBody>
+      </p:sp>
+      <p:sp>
+        <p:nvSpPr>
+          <p:cNvPr id="4" name="Text 2"/>
+          <p:cNvSpPr/>
+          <p:nvPr/>
+        </p:nvSpPr>
+        <p:spPr>
+          <a:xfrm>
+            <a:off x="1051560" y="310896"/>
+            <a:ext cx="7726680" cy="292608"/>
+          </a:xfrm>
+          <a:prstGeom prst="rect">
+            <a:avLst/>
+          </a:prstGeom>
+          <a:noFill/>
+          <a:ln/>
+        </p:spPr>
+        <p:txBody>
+          <a:bodyPr wrap="square" lIns="0" tIns="0" rIns="0" bIns="0" rtlCol="0" anchor="ctr"/>
+          <a:lstStyle/>
+          <a:p>
+            <a:pPr algn="l" indent="0" marL="0">
+              <a:buNone/>
+            </a:pPr>
+            <a:r>
+              <a:rPr lang="en-US" sz="2000" b="1" dirty="0">
+                <a:solidFill>
+                  <a:srgbClr val="111111"/>
+                </a:solidFill>
+                <a:latin typeface="Times New Roman" pitchFamily="34" charset="0"/>
+                <a:ea typeface="Times New Roman" pitchFamily="34" charset="-122"/>
+                <a:cs typeface="Times New Roman" pitchFamily="34" charset="-120"/>
+              </a:rPr>
+              <a:t>Feuille d'exercices — Layout type</a:t>
+            </a:r>
+            <a:endParaRPr lang="en-US" sz="2000" dirty="0"/>
+          </a:p>
+        </p:txBody>
+      </p:sp>
+      <p:sp>
+        <p:nvSpPr>
+          <p:cNvPr id="5" name="Shape 3"/>
+          <p:cNvSpPr/>
+          <p:nvPr/>
+        </p:nvSpPr>
+        <p:spPr>
+          <a:xfrm>
+            <a:off x="365760" y="658368"/>
+            <a:ext cx="8412480" cy="0"/>
+          </a:xfrm>
+          <a:prstGeom prst="line">
+            <a:avLst/>
+          </a:prstGeom>
+          <a:noFill/>
+          <a:ln w="6350">
+            <a:solidFill>
+              <a:srgbClr val="CCCCCC"/>
+            </a:solidFill>
+            <a:prstDash val="solid"/>
+          </a:ln>
+        </p:spPr>
+      </p:sp>
+      <p:sp>
+        <p:nvSpPr>
+          <p:cNvPr id="6" name="Shape 4"/>
+          <p:cNvSpPr/>
+          <p:nvPr/>
+        </p:nvSpPr>
+        <p:spPr>
+          <a:xfrm>
+            <a:off x="365760" y="822960"/>
+            <a:ext cx="8412480" cy="1170432"/>
+          </a:xfrm>
+          <a:prstGeom prst="rect">
+            <a:avLst/>
+          </a:prstGeom>
+          <a:solidFill>
+            <a:srgbClr val="FFFFFF"/>
+          </a:solidFill>
+          <a:ln w="7620">
+            <a:solidFill>
+              <a:srgbClr val="111111"/>
+            </a:solidFill>
+            <a:prstDash val="solid"/>
+          </a:ln>
+        </p:spPr>
+      </p:sp>
+      <p:sp>
+        <p:nvSpPr>
+          <p:cNvPr id="7" name="Text 5"/>
+          <p:cNvSpPr/>
+          <p:nvPr/>
+        </p:nvSpPr>
+        <p:spPr>
+          <a:xfrm>
+            <a:off x="512064" y="896112"/>
+            <a:ext cx="2011680" cy="237744"/>
+          </a:xfrm>
+          <a:prstGeom prst="rect">
+            <a:avLst/>
+          </a:prstGeom>
+          <a:noFill/>
+          <a:ln/>
+        </p:spPr>
+        <p:txBody>
+          <a:bodyPr wrap="square" lIns="0" tIns="0" rIns="0" bIns="0" rtlCol="0" anchor="ctr"/>
+          <a:lstStyle/>
+          <a:p>
+            <a:pPr algn="l" indent="0" marL="0">
+              <a:buNone/>
+            </a:pPr>
+            <a:r>
+              <a:rPr lang="en-US" sz="1100" b="1" dirty="0">
+                <a:solidFill>
+                  <a:srgbClr val="111111"/>
+                </a:solidFill>
+                <a:latin typeface="Times New Roman" pitchFamily="34" charset="0"/>
+                <a:ea typeface="Times New Roman" pitchFamily="34" charset="-122"/>
+                <a:cs typeface="Times New Roman" pitchFamily="34" charset="-120"/>
+              </a:rPr>
+              <a:t>Exercice 3.1</a:t>
+            </a:r>
+            <a:endParaRPr lang="en-US" sz="1100" dirty="0"/>
+          </a:p>
+        </p:txBody>
+      </p:sp>
+      <p:sp>
+        <p:nvSpPr>
+          <p:cNvPr id="8" name="Text 6"/>
+          <p:cNvSpPr/>
+          <p:nvPr/>
+        </p:nvSpPr>
+        <p:spPr>
+          <a:xfrm>
+            <a:off x="2468880" y="905256"/>
+            <a:ext cx="6126480" cy="219456"/>
+          </a:xfrm>
+          <a:prstGeom prst="rect">
+            <a:avLst/>
+          </a:prstGeom>
+          <a:noFill/>
+          <a:ln/>
+        </p:spPr>
+        <p:txBody>
+          <a:bodyPr wrap="square" lIns="0" tIns="0" rIns="0" bIns="0" rtlCol="0" anchor="ctr"/>
+          <a:lstStyle/>
+          <a:p>
+            <a:pPr algn="l" indent="0" marL="0">
+              <a:buNone/>
+            </a:pPr>
+            <a:r>
+              <a:rPr lang="en-US" sz="1000" i="1" dirty="0">
+                <a:solidFill>
+                  <a:srgbClr val="666666"/>
+                </a:solidFill>
+                <a:latin typeface="Times New Roman" pitchFamily="34" charset="0"/>
+                <a:ea typeface="Times New Roman" pitchFamily="34" charset="-122"/>
+                <a:cs typeface="Times New Roman" pitchFamily="34" charset="-120"/>
+              </a:rPr>
+              <a:t>— Convergence uniforme</a:t>
+            </a:r>
+            <a:endParaRPr lang="en-US" sz="1000" dirty="0"/>
+          </a:p>
+        </p:txBody>
+      </p:sp>
+      <p:sp>
+        <p:nvSpPr>
+          <p:cNvPr id="9" name="Shape 7"/>
+          <p:cNvSpPr/>
+          <p:nvPr/>
+        </p:nvSpPr>
+        <p:spPr>
+          <a:xfrm>
+            <a:off x="512064" y="1152144"/>
+            <a:ext cx="8119872" cy="0"/>
+          </a:xfrm>
+          <a:prstGeom prst="line">
+            <a:avLst/>
+          </a:prstGeom>
+          <a:noFill/>
+          <a:ln w="3810">
+            <a:solidFill>
+              <a:srgbClr val="CCCCCC"/>
+            </a:solidFill>
+            <a:prstDash val="solid"/>
+          </a:ln>
+        </p:spPr>
+      </p:sp>
+      <p:sp>
+        <p:nvSpPr>
+          <p:cNvPr id="10" name="Text 8"/>
+          <p:cNvSpPr/>
+          <p:nvPr/>
+        </p:nvSpPr>
+        <p:spPr>
+          <a:xfrm>
+            <a:off x="512064" y="1225296"/>
+            <a:ext cx="8119872" cy="694944"/>
+          </a:xfrm>
+          <a:prstGeom prst="rect">
+            <a:avLst/>
+          </a:prstGeom>
+          <a:noFill/>
+          <a:ln/>
+        </p:spPr>
+        <p:txBody>
+          <a:bodyPr wrap="square" lIns="0" tIns="0" rIns="0" bIns="0" rtlCol="0" anchor="ctr"/>
+          <a:lstStyle/>
+          <a:p>
+            <a:pPr algn="l" indent="0" marL="0">
+              <a:buNone/>
+            </a:pPr>
+            <a:r>
+              <a:rPr lang="en-US" sz="1100" dirty="0">
+                <a:solidFill>
+                  <a:srgbClr val="333333"/>
+                </a:solidFill>
+                <a:latin typeface="Times New Roman" pitchFamily="34" charset="0"/>
+                <a:ea typeface="Times New Roman" pitchFamily="34" charset="-122"/>
+                <a:cs typeface="Times New Roman" pitchFamily="34" charset="-120"/>
+              </a:rPr>
+              <a:t>Montrer que la suite fₙ(x) = x / (1 + nx²) converge uniformément vers 0 sur ℝ. On pourra utiliser l'inégalité AM-GM.</a:t>
+            </a:r>
+            <a:endParaRPr lang="en-US" sz="1100" dirty="0"/>
+          </a:p>
+        </p:txBody>
+      </p:sp>
+      <p:sp>
+        <p:nvSpPr>
+          <p:cNvPr id="11" name="Shape 9"/>
+          <p:cNvSpPr/>
+          <p:nvPr/>
+        </p:nvSpPr>
+        <p:spPr>
+          <a:xfrm>
+            <a:off x="365760" y="2130552"/>
+            <a:ext cx="8412480" cy="1170432"/>
+          </a:xfrm>
+          <a:prstGeom prst="rect">
+            <a:avLst/>
+          </a:prstGeom>
+          <a:solidFill>
+            <a:srgbClr val="FFFFFF"/>
+          </a:solidFill>
+          <a:ln w="7620">
+            <a:solidFill>
+              <a:srgbClr val="111111"/>
+            </a:solidFill>
+            <a:prstDash val="solid"/>
+          </a:ln>
+        </p:spPr>
+      </p:sp>
+      <p:sp>
+        <p:nvSpPr>
+          <p:cNvPr id="12" name="Text 10"/>
+          <p:cNvSpPr/>
+          <p:nvPr/>
+        </p:nvSpPr>
+        <p:spPr>
+          <a:xfrm>
+            <a:off x="512064" y="2203704"/>
+            <a:ext cx="2011680" cy="237744"/>
+          </a:xfrm>
+          <a:prstGeom prst="rect">
+            <a:avLst/>
+          </a:prstGeom>
+          <a:noFill/>
+          <a:ln/>
+        </p:spPr>
+        <p:txBody>
+          <a:bodyPr wrap="square" lIns="0" tIns="0" rIns="0" bIns="0" rtlCol="0" anchor="ctr"/>
+          <a:lstStyle/>
+          <a:p>
+            <a:pPr algn="l" indent="0" marL="0">
+              <a:buNone/>
+            </a:pPr>
+            <a:r>
+              <a:rPr lang="en-US" sz="1100" b="1" dirty="0">
+                <a:solidFill>
+                  <a:srgbClr val="111111"/>
+                </a:solidFill>
+                <a:latin typeface="Times New Roman" pitchFamily="34" charset="0"/>
+                <a:ea typeface="Times New Roman" pitchFamily="34" charset="-122"/>
+                <a:cs typeface="Times New Roman" pitchFamily="34" charset="-120"/>
+              </a:rPr>
+              <a:t>Exercice 3.2</a:t>
+            </a:r>
+            <a:endParaRPr lang="en-US" sz="1100" dirty="0"/>
+          </a:p>
+        </p:txBody>
+      </p:sp>
+      <p:sp>
+        <p:nvSpPr>
+          <p:cNvPr id="13" name="Text 11"/>
+          <p:cNvSpPr/>
+          <p:nvPr/>
+        </p:nvSpPr>
+        <p:spPr>
+          <a:xfrm>
+            <a:off x="2468880" y="2212848"/>
+            <a:ext cx="6126480" cy="219456"/>
+          </a:xfrm>
+          <a:prstGeom prst="rect">
+            <a:avLst/>
+          </a:prstGeom>
+          <a:noFill/>
+          <a:ln/>
+        </p:spPr>
+        <p:txBody>
+          <a:bodyPr wrap="square" lIns="0" tIns="0" rIns="0" bIns="0" rtlCol="0" anchor="ctr"/>
+          <a:lstStyle/>
+          <a:p>
+            <a:pPr algn="l" indent="0" marL="0">
+              <a:buNone/>
+            </a:pPr>
+            <a:r>
+              <a:rPr lang="en-US" sz="1000" i="1" dirty="0">
+                <a:solidFill>
+                  <a:srgbClr val="666666"/>
+                </a:solidFill>
+                <a:latin typeface="Times New Roman" pitchFamily="34" charset="0"/>
+                <a:ea typeface="Times New Roman" pitchFamily="34" charset="-122"/>
+                <a:cs typeface="Times New Roman" pitchFamily="34" charset="-120"/>
+              </a:rPr>
+              <a:t>— Tri par fusion</a:t>
+            </a:r>
+            <a:endParaRPr lang="en-US" sz="1000" dirty="0"/>
+          </a:p>
+        </p:txBody>
+      </p:sp>
+      <p:sp>
+        <p:nvSpPr>
+          <p:cNvPr id="14" name="Shape 12"/>
+          <p:cNvSpPr/>
+          <p:nvPr/>
+        </p:nvSpPr>
+        <p:spPr>
+          <a:xfrm>
+            <a:off x="512064" y="2459736"/>
+            <a:ext cx="8119872" cy="0"/>
+          </a:xfrm>
+          <a:prstGeom prst="line">
+            <a:avLst/>
+          </a:prstGeom>
+          <a:noFill/>
+          <a:ln w="3810">
+            <a:solidFill>
+              <a:srgbClr val="CCCCCC"/>
+            </a:solidFill>
+            <a:prstDash val="solid"/>
+          </a:ln>
+        </p:spPr>
+      </p:sp>
+      <p:sp>
+        <p:nvSpPr>
+          <p:cNvPr id="15" name="Text 13"/>
+          <p:cNvSpPr/>
+          <p:nvPr/>
+        </p:nvSpPr>
+        <p:spPr>
+          <a:xfrm>
+            <a:off x="512064" y="2532888"/>
+            <a:ext cx="8119872" cy="694944"/>
+          </a:xfrm>
+          <a:prstGeom prst="rect">
+            <a:avLst/>
+          </a:prstGeom>
+          <a:noFill/>
+          <a:ln/>
+        </p:spPr>
+        <p:txBody>
+          <a:bodyPr wrap="square" lIns="0" tIns="0" rIns="0" bIns="0" rtlCol="0" anchor="ctr"/>
+          <a:lstStyle/>
+          <a:p>
+            <a:pPr algn="l" indent="0" marL="0">
+              <a:buNone/>
+            </a:pPr>
+            <a:r>
+              <a:rPr lang="en-US" sz="1100" dirty="0">
+                <a:solidFill>
+                  <a:srgbClr val="333333"/>
+                </a:solidFill>
+                <a:latin typeface="Times New Roman" pitchFamily="34" charset="0"/>
+                <a:ea typeface="Times New Roman" pitchFamily="34" charset="-122"/>
+                <a:cs typeface="Times New Roman" pitchFamily="34" charset="-120"/>
+              </a:rPr>
+              <a:t>Établir la récurrence T(n) = 2T(n/2) + Θ(n) et en déduire T(n) = Θ(n log n) par le théorème maître (cas 2).</a:t>
+            </a:r>
+            <a:endParaRPr lang="en-US" sz="1100" dirty="0"/>
+          </a:p>
+        </p:txBody>
+      </p:sp>
+      <p:sp>
+        <p:nvSpPr>
+          <p:cNvPr id="16" name="Shape 14"/>
+          <p:cNvSpPr/>
+          <p:nvPr/>
+        </p:nvSpPr>
+        <p:spPr>
+          <a:xfrm>
+            <a:off x="365760" y="3438144"/>
+            <a:ext cx="8412480" cy="1170432"/>
+          </a:xfrm>
+          <a:prstGeom prst="rect">
+            <a:avLst/>
+          </a:prstGeom>
+          <a:solidFill>
+            <a:srgbClr val="FFFFFF"/>
+          </a:solidFill>
+          <a:ln w="7620">
+            <a:solidFill>
+              <a:srgbClr val="111111"/>
+            </a:solidFill>
+            <a:prstDash val="solid"/>
+          </a:ln>
+        </p:spPr>
+      </p:sp>
+      <p:sp>
+        <p:nvSpPr>
+          <p:cNvPr id="17" name="Text 15"/>
+          <p:cNvSpPr/>
+          <p:nvPr/>
+        </p:nvSpPr>
+        <p:spPr>
+          <a:xfrm>
+            <a:off x="512064" y="3511296"/>
+            <a:ext cx="2011680" cy="237744"/>
+          </a:xfrm>
+          <a:prstGeom prst="rect">
+            <a:avLst/>
+          </a:prstGeom>
+          <a:noFill/>
+          <a:ln/>
+        </p:spPr>
+        <p:txBody>
+          <a:bodyPr wrap="square" lIns="0" tIns="0" rIns="0" bIns="0" rtlCol="0" anchor="ctr"/>
+          <a:lstStyle/>
+          <a:p>
+            <a:pPr algn="l" indent="0" marL="0">
+              <a:buNone/>
+            </a:pPr>
+            <a:r>
+              <a:rPr lang="en-US" sz="1100" b="1" dirty="0">
+                <a:solidFill>
+                  <a:srgbClr val="111111"/>
+                </a:solidFill>
+                <a:latin typeface="Times New Roman" pitchFamily="34" charset="0"/>
+                <a:ea typeface="Times New Roman" pitchFamily="34" charset="-122"/>
+                <a:cs typeface="Times New Roman" pitchFamily="34" charset="-120"/>
+              </a:rPr>
+              <a:t>Exercice 3.3</a:t>
+            </a:r>
+            <a:endParaRPr lang="en-US" sz="1100" dirty="0"/>
+          </a:p>
+        </p:txBody>
+      </p:sp>
+      <p:sp>
+        <p:nvSpPr>
+          <p:cNvPr id="18" name="Text 16"/>
+          <p:cNvSpPr/>
+          <p:nvPr/>
+        </p:nvSpPr>
+        <p:spPr>
+          <a:xfrm>
+            <a:off x="2468880" y="3520440"/>
+            <a:ext cx="6126480" cy="219456"/>
+          </a:xfrm>
+          <a:prstGeom prst="rect">
+            <a:avLst/>
+          </a:prstGeom>
+          <a:noFill/>
+          <a:ln/>
+        </p:spPr>
+        <p:txBody>
+          <a:bodyPr wrap="square" lIns="0" tIns="0" rIns="0" bIns="0" rtlCol="0" anchor="ctr"/>
+          <a:lstStyle/>
+          <a:p>
+            <a:pPr algn="l" indent="0" marL="0">
+              <a:buNone/>
+            </a:pPr>
+            <a:r>
+              <a:rPr lang="en-US" sz="1000" i="1" dirty="0">
+                <a:solidFill>
+                  <a:srgbClr val="666666"/>
+                </a:solidFill>
+                <a:latin typeface="Times New Roman" pitchFamily="34" charset="0"/>
+                <a:ea typeface="Times New Roman" pitchFamily="34" charset="-122"/>
+                <a:cs typeface="Times New Roman" pitchFamily="34" charset="-120"/>
+              </a:rPr>
+              <a:t>— Inégalité de Jensen</a:t>
+            </a:r>
+            <a:endParaRPr lang="en-US" sz="1000" dirty="0"/>
+          </a:p>
+        </p:txBody>
+      </p:sp>
+      <p:sp>
+        <p:nvSpPr>
+          <p:cNvPr id="19" name="Shape 17"/>
+          <p:cNvSpPr/>
+          <p:nvPr/>
+        </p:nvSpPr>
+        <p:spPr>
+          <a:xfrm>
+            <a:off x="512064" y="3767328"/>
+            <a:ext cx="8119872" cy="0"/>
+          </a:xfrm>
+          <a:prstGeom prst="line">
+            <a:avLst/>
+          </a:prstGeom>
+          <a:noFill/>
+          <a:ln w="3810">
+            <a:solidFill>
+              <a:srgbClr val="CCCCCC"/>
+            </a:solidFill>
+            <a:prstDash val="solid"/>
+          </a:ln>
+        </p:spPr>
+      </p:sp>
+      <p:sp>
+        <p:nvSpPr>
+          <p:cNvPr id="20" name="Text 18"/>
+          <p:cNvSpPr/>
+          <p:nvPr/>
+        </p:nvSpPr>
+        <p:spPr>
+          <a:xfrm>
+            <a:off x="512064" y="3840480"/>
+            <a:ext cx="8119872" cy="694944"/>
+          </a:xfrm>
+          <a:prstGeom prst="rect">
+            <a:avLst/>
+          </a:prstGeom>
+          <a:noFill/>
+          <a:ln/>
+        </p:spPr>
+        <p:txBody>
+          <a:bodyPr wrap="square" lIns="0" tIns="0" rIns="0" bIns="0" rtlCol="0" anchor="ctr"/>
+          <a:lstStyle/>
+          <a:p>
+            <a:pPr algn="l" indent="0" marL="0">
+              <a:buNone/>
+            </a:pPr>
+            <a:r>
+              <a:rPr lang="en-US" sz="1100" dirty="0">
+                <a:solidFill>
+                  <a:srgbClr val="333333"/>
+                </a:solidFill>
+                <a:latin typeface="Times New Roman" pitchFamily="34" charset="0"/>
+                <a:ea typeface="Times New Roman" pitchFamily="34" charset="-122"/>
+                <a:cs typeface="Times New Roman" pitchFamily="34" charset="-120"/>
+              </a:rPr>
+              <a:t>Soit φ : ℝ → ℝ convexe et X une variable aléatoire intégrable. Démontrer φ(𝔼[X]) ≤ 𝔼[φ(X)] en utilisant la définition de la convexité.</a:t>
+            </a:r>
+            <a:endParaRPr lang="en-US" sz="1100" dirty="0"/>
+          </a:p>
+        </p:txBody>
+      </p:sp>
+      <p:sp>
+        <p:nvSpPr>
+          <p:cNvPr id="21" name="Text 19"/>
+          <p:cNvSpPr/>
+          <p:nvPr/>
+        </p:nvSpPr>
+        <p:spPr>
+          <a:xfrm>
+            <a:off x="365760" y="4663440"/>
+            <a:ext cx="8412480" cy="182880"/>
+          </a:xfrm>
+          <a:prstGeom prst="rect">
+            <a:avLst/>
+          </a:prstGeom>
+          <a:noFill/>
+          <a:ln/>
+        </p:spPr>
+        <p:txBody>
+          <a:bodyPr wrap="square" lIns="0" tIns="0" rIns="0" bIns="0" rtlCol="0" anchor="ctr"/>
+          <a:lstStyle/>
+          <a:p>
+            <a:pPr algn="ctr" indent="0" marL="0">
+              <a:buNone/>
+            </a:pPr>
+            <a:r>
+              <a:rPr lang="en-US" sz="900" i="1" dirty="0">
+                <a:solidFill>
+                  <a:srgbClr val="AAAAAA"/>
+                </a:solidFill>
+                <a:latin typeface="Times New Roman" pitchFamily="34" charset="0"/>
+                <a:ea typeface="Times New Roman" pitchFamily="34" charset="-122"/>
+                <a:cs typeface="Times New Roman" pitchFamily="34" charset="-120"/>
+              </a:rPr>
+              <a:t>Les corrections complètes sont disponibles dans les templates DOCX et LaTeX.</a:t>
+            </a:r>
+            <a:endParaRPr lang="en-US" sz="900" dirty="0"/>
+          </a:p>
+        </p:txBody>
+      </p:sp>
+      <p:sp>
+        <p:nvSpPr>
+          <p:cNvPr id="22" name="Shape 20"/>
+          <p:cNvSpPr/>
+          <p:nvPr/>
+        </p:nvSpPr>
+        <p:spPr>
+          <a:xfrm>
+            <a:off x="365760" y="4892040"/>
+            <a:ext cx="8412480" cy="0"/>
+          </a:xfrm>
+          <a:prstGeom prst="line">
+            <a:avLst/>
+          </a:prstGeom>
+          <a:noFill/>
+          <a:ln w="5080">
+            <a:solidFill>
+              <a:srgbClr val="CCCCCC"/>
+            </a:solidFill>
+            <a:prstDash val="solid"/>
+          </a:ln>
+        </p:spPr>
+      </p:sp>
+      <p:sp>
+        <p:nvSpPr>
+          <p:cNvPr id="23" name="Text 21"/>
+          <p:cNvSpPr/>
+          <p:nvPr/>
+        </p:nvSpPr>
+        <p:spPr>
+          <a:xfrm>
+            <a:off x="7772400" y="4919472"/>
+            <a:ext cx="1005840" cy="164592"/>
+          </a:xfrm>
+          <a:prstGeom prst="rect">
+            <a:avLst/>
+          </a:prstGeom>
+          <a:noFill/>
+          <a:ln/>
+        </p:spPr>
+        <p:txBody>
+          <a:bodyPr wrap="square" lIns="0" tIns="0" rIns="0" bIns="0" rtlCol="0" anchor="ctr"/>
+          <a:lstStyle/>
+          <a:p>
+            <a:pPr algn="r" indent="0" marL="0">
+              <a:buNone/>
+            </a:pPr>
+            <a:r>
+              <a:rPr lang="en-US" sz="800" dirty="0">
+                <a:solidFill>
+                  <a:srgbClr val="AAAAAA"/>
+                </a:solidFill>
+                <a:latin typeface="Courier New" pitchFamily="34" charset="0"/>
+                <a:ea typeface="Courier New" pitchFamily="34" charset="-122"/>
+                <a:cs typeface="Courier New" pitchFamily="34" charset="-120"/>
+              </a:rPr>
+              <a:t>11 / 11</a:t>
+            </a:r>
+            <a:endParaRPr lang="en-US" sz="800" dirty="0"/>
+          </a:p>
+        </p:txBody>
+      </p:sp>
+      <p:sp>
+        <p:nvSpPr>
+          <p:cNvPr id="24" name="Text 22"/>
+          <p:cNvSpPr/>
+          <p:nvPr/>
+        </p:nvSpPr>
+        <p:spPr>
+          <a:xfrm>
+            <a:off x="365760" y="4919472"/>
+            <a:ext cx="2743200" cy="164592"/>
+          </a:xfrm>
+          <a:prstGeom prst="rect">
+            <a:avLst/>
+          </a:prstGeom>
+          <a:noFill/>
+          <a:ln/>
+        </p:spPr>
+        <p:txBody>
+          <a:bodyPr wrap="square" lIns="0" tIns="0" rIns="0" bIns="0" rtlCol="0" anchor="ctr"/>
+          <a:lstStyle/>
+          <a:p>
+            <a:pPr algn="l" indent="0" marL="0">
+              <a:buNone/>
+            </a:pPr>
+            <a:r>
+              <a:rPr lang="en-US" sz="800" i="1" dirty="0">
+                <a:solidFill>
+                  <a:srgbClr val="AAAAAA"/>
+                </a:solidFill>
+                <a:latin typeface="Times New Roman" pitchFamily="34" charset="0"/>
+                <a:ea typeface="Times New Roman" pitchFamily="34" charset="-122"/>
+                <a:cs typeface="Times New Roman" pitchFamily="34" charset="-120"/>
+              </a:rPr>
+              <a:t>Ars Typographica</a:t>
+            </a:r>
+            <a:endParaRPr lang="en-US" sz="800" dirty="0"/>
+          </a:p>
+        </p:txBody>
+      </p:sp>
+    </p:spTree>
+  </p:cSld>
+  <p:clrMapOvr>
+    <a:masterClrMapping/>
+  </p:clrMapOvr>
+</p:sld>
+</file>
+
 <file path=ppt/slides/slide2.xml><?xml version="1.0" encoding="utf-8"?>
 <p:sld xmlns:a="http://schemas.openxmlformats.org/drawingml/2006/main" xmlns:r="http://schemas.openxmlformats.org/officeDocument/2006/relationships" xmlns:p="http://schemas.openxmlformats.org/presentationml/2006/main">
   <p:cSld name="Slide 2">
@@ -2562,7 +4729,7 @@
                 <a:ea typeface="Courier New" pitchFamily="34" charset="-122"/>
                 <a:cs typeface="Courier New" pitchFamily="34" charset="-120"/>
               </a:rPr>
-              <a:t>2 / 9</a:t>
+              <a:t>2 / 11</a:t>
             </a:r>
             <a:endParaRPr lang="en-US" sz="800" dirty="0"/>
           </a:p>
@@ -3170,7 +5337,7 @@
                 <a:ea typeface="Courier New" pitchFamily="34" charset="-122"/>
                 <a:cs typeface="Courier New" pitchFamily="34" charset="-120"/>
               </a:rPr>
-              <a:t>3 / 9</a:t>
+              <a:t>3 / 11</a:t>
             </a:r>
             <a:endParaRPr lang="en-US" sz="800" dirty="0"/>
           </a:p>
@@ -4198,7 +6365,7 @@
                 <a:ea typeface="Courier New" pitchFamily="34" charset="-122"/>
                 <a:cs typeface="Courier New" pitchFamily="34" charset="-120"/>
               </a:rPr>
-              <a:t>4 / 9</a:t>
+              <a:t>4 / 11</a:t>
             </a:r>
             <a:endParaRPr lang="en-US" sz="800" dirty="0"/>
           </a:p>
@@ -4914,7 +7081,7 @@
                 <a:ea typeface="Courier New" pitchFamily="34" charset="-122"/>
                 <a:cs typeface="Courier New" pitchFamily="34" charset="-120"/>
               </a:rPr>
-              <a:t>5 / 9</a:t>
+              <a:t>5 / 11</a:t>
             </a:r>
             <a:endParaRPr lang="en-US" sz="800" dirty="0"/>
           </a:p>
@@ -7130,7 +9297,7 @@
                 <a:ea typeface="Courier New" pitchFamily="34" charset="-122"/>
                 <a:cs typeface="Courier New" pitchFamily="34" charset="-120"/>
               </a:rPr>
-              <a:t>6 / 9</a:t>
+              <a:t>6 / 11</a:t>
             </a:r>
             <a:endParaRPr lang="en-US" sz="800" dirty="0"/>
           </a:p>
@@ -7640,7 +9807,7 @@
                 <a:ea typeface="Courier New" pitchFamily="34" charset="-122"/>
                 <a:cs typeface="Courier New" pitchFamily="34" charset="-120"/>
               </a:rPr>
-              <a:t>7 / 9</a:t>
+              <a:t>7 / 11</a:t>
             </a:r>
             <a:endParaRPr lang="en-US" sz="800" dirty="0"/>
           </a:p>
@@ -8280,7 +10447,7 @@
                 <a:ea typeface="Courier New" pitchFamily="34" charset="-122"/>
                 <a:cs typeface="Courier New" pitchFamily="34" charset="-120"/>
               </a:rPr>
-              <a:t>8 / 9</a:t>
+              <a:t>8 / 11</a:t>
             </a:r>
             <a:endParaRPr lang="en-US" sz="800" dirty="0"/>
           </a:p>

</xml_diff>